<commit_message>
Thoracic deep-dive slide: drop note lines, tag reasons and events inline
Event tags moved onto the chart axis (8/26 Francisco + two-stage, 9/9 trachea
conflict), defect reasons shown as name-count tags, footnote captions removed.

Co-Authored-By: Claude Fable 5 <noreply@anthropic.com>
Claude-Session: https://claude.ai/code/session_014UGcEfvuC9NvQ5rauRTTbR
</commit_message>
<xml_diff>
--- a/QC inspections suppliers/Nahunta_Thoracics_DeepDive.pptx
+++ b/QC inspections suppliers/Nahunta_Thoracics_DeepDive.pptx
@@ -183,10 +183,10 @@
                     <c:v>8/19</c:v>
                   </c:pt>
                   <c:pt idx="4">
-                    <c:v>8/26 ①②</c:v>
+                    <c:v>8/26 · Francisco + two-stage</c:v>
                   </c:pt>
                   <c:pt idx="5">
-                    <c:v>9/9 ③</c:v>
+                    <c:v>9/9 · trachea conflict</c:v>
                   </c:pt>
                 </c:lvl>
               </c:multiLvlStrCache>
@@ -275,7 +275,7 @@
           <a:lstStyle/>
           <a:p>
             <a:pPr>
-              <a:defRPr sz="900" b="0" i="0" u="none" strike="noStrike">
+              <a:defRPr sz="800" b="0" i="0" u="none" strike="noStrike">
                 <a:solidFill>
                   <a:srgbClr val="1F2937"/>
                 </a:solidFill>
@@ -1245,7 +1245,7 @@
                 <a:ea typeface="Calibri" pitchFamily="34" charset="-122"/>
                 <a:cs typeface="Calibri" pitchFamily="34" charset="-120"/>
               </a:rPr>
-              <a:t>Harvest yield by visit — usable ÷ blocks at harvest (the comparable series)</a:t>
+              <a:t>Harvest yield by visit — usable ÷ blocks at harvest</a:t>
             </a:r>
             <a:endParaRPr lang="en-US" sz="1000" dirty="0"/>
           </a:p>
@@ -1259,7 +1259,7 @@
         </p:nvGraphicFramePr>
         <p:xfrm>
           <a:off x="411480" y="1261872"/>
-          <a:ext cx="5577840" cy="1691640"/>
+          <a:ext cx="5577840" cy="1874520"/>
         </p:xfrm>
         <a:graphic xmlns:a="http://schemas.openxmlformats.org/drawingml/2006/main">
           <a:graphicData uri="http://schemas.openxmlformats.org/drawingml/2006/chart">
@@ -1270,45 +1270,6 @@
       <p:sp>
         <p:nvSpPr>
           <p:cNvPr id="6" name="Text 3"/>
-          <p:cNvSpPr/>
-          <p:nvPr/>
-        </p:nvSpPr>
-        <p:spPr>
-          <a:xfrm>
-            <a:off x="411480" y="2999232"/>
-            <a:ext cx="5577840" cy="274320"/>
-          </a:xfrm>
-          <a:prstGeom prst="rect">
-            <a:avLst/>
-          </a:prstGeom>
-          <a:noFill/>
-          <a:ln/>
-        </p:spPr>
-        <p:txBody>
-          <a:bodyPr wrap="square" lIns="0" tIns="0" rIns="0" bIns="0" rtlCol="0" anchor="ctr"/>
-          <a:lstStyle/>
-          <a:p>
-            <a:pPr indent="0" marL="0">
-              <a:buNone/>
-            </a:pPr>
-            <a:r>
-              <a:rPr lang="en-US" sz="760" i="1" dirty="0">
-                <a:solidFill>
-                  <a:srgbClr val="6B7280"/>
-                </a:solidFill>
-                <a:latin typeface="Calibri" pitchFamily="34" charset="0"/>
-                <a:ea typeface="Calibri" pitchFamily="34" charset="-122"/>
-                <a:cs typeface="Calibri" pitchFamily="34" charset="-120"/>
-              </a:rPr>
-              <a:t>① Francisco's team engaged   ② two-inspection process starts (Jordan screens at harvest, our QC inspects what he passes)   ③ trachea conflict hits</a:t>
-            </a:r>
-            <a:endParaRPr lang="en-US" sz="760" dirty="0"/>
-          </a:p>
-        </p:txBody>
-      </p:sp>
-      <p:sp>
-        <p:nvSpPr>
-          <p:cNvPr id="7" name="Text 4"/>
           <p:cNvSpPr/>
           <p:nvPr/>
         </p:nvSpPr>
@@ -5539,52 +5500,13 @@
       </p:graphicFrame>
       <p:sp>
         <p:nvSpPr>
-          <p:cNvPr id="9" name="Text 5"/>
+          <p:cNvPr id="8" name="Text 4"/>
           <p:cNvSpPr/>
           <p:nvPr/>
         </p:nvSpPr>
         <p:spPr>
           <a:xfrm>
-            <a:off x="6172200" y="3054096"/>
-            <a:ext cx="5577840" cy="237744"/>
-          </a:xfrm>
-          <a:prstGeom prst="rect">
-            <a:avLst/>
-          </a:prstGeom>
-          <a:noFill/>
-          <a:ln/>
-        </p:spPr>
-        <p:txBody>
-          <a:bodyPr wrap="square" lIns="0" tIns="0" rIns="0" bIns="0" rtlCol="0" anchor="ctr"/>
-          <a:lstStyle/>
-          <a:p>
-            <a:pPr indent="0" marL="0">
-              <a:buNone/>
-            </a:pPr>
-            <a:r>
-              <a:rPr lang="en-US" sz="760" i="1" dirty="0">
-                <a:solidFill>
-                  <a:srgbClr val="6B7280"/>
-                </a:solidFill>
-                <a:latin typeface="Calibri" pitchFamily="34" charset="0"/>
-                <a:ea typeface="Calibri" pitchFamily="34" charset="-122"/>
-                <a:cs typeface="Calibri" pitchFamily="34" charset="-120"/>
-              </a:rPr>
-              <a:t>Single-stage = our tech inspected the whole harvest. Two-stage = QC accept is of what Jordan passed. 8/12: sheet lists 12 reasons vs 11 fails (±1).</a:t>
-            </a:r>
-            <a:endParaRPr lang="en-US" sz="760" dirty="0"/>
-          </a:p>
-        </p:txBody>
-      </p:sp>
-      <p:sp>
-        <p:nvSpPr>
-          <p:cNvPr id="10" name="Text 6"/>
-          <p:cNvSpPr/>
-          <p:nvPr/>
-        </p:nvSpPr>
-        <p:spPr>
-          <a:xfrm>
-            <a:off x="411480" y="3401568"/>
+            <a:off x="411480" y="3456432"/>
             <a:ext cx="5577840" cy="219456"/>
           </a:xfrm>
           <a:prstGeom prst="rect">
@@ -5609,7 +5531,7 @@
                 <a:ea typeface="Calibri" pitchFamily="34" charset="-122"/>
                 <a:cs typeface="Calibri" pitchFamily="34" charset="-120"/>
               </a:rPr>
-              <a:t>What's failing — one damage mode</a:t>
+              <a:t>What's failing — reasons</a:t>
             </a:r>
             <a:endParaRPr lang="en-US" sz="1000" dirty="0"/>
           </a:p>
@@ -5617,14 +5539,14 @@
       </p:sp>
       <p:sp>
         <p:nvSpPr>
-          <p:cNvPr id="11" name="Shape 7"/>
+          <p:cNvPr id="9" name="Shape 5"/>
           <p:cNvSpPr/>
           <p:nvPr/>
         </p:nvSpPr>
         <p:spPr>
           <a:xfrm>
-            <a:off x="411480" y="3721608"/>
-            <a:ext cx="2834640" cy="146304"/>
+            <a:off x="411480" y="3794760"/>
+            <a:ext cx="2743200" cy="146304"/>
           </a:xfrm>
           <a:prstGeom prst="rect">
             <a:avLst/>
@@ -5637,14 +5559,14 @@
       </p:sp>
       <p:sp>
         <p:nvSpPr>
-          <p:cNvPr id="12" name="Text 8"/>
+          <p:cNvPr id="10" name="Text 6"/>
           <p:cNvSpPr/>
           <p:nvPr/>
         </p:nvSpPr>
         <p:spPr>
           <a:xfrm>
-            <a:off x="3337560" y="3657600"/>
-            <a:ext cx="8321040" cy="274320"/>
+            <a:off x="3246120" y="3730752"/>
+            <a:ext cx="8412480" cy="274320"/>
           </a:xfrm>
           <a:prstGeom prst="rect">
             <a:avLst/>
@@ -5660,7 +5582,7 @@
               <a:buNone/>
             </a:pPr>
             <a:r>
-              <a:rPr lang="en-US" sz="860" b="1" dirty="0">
+              <a:rPr lang="en-US" sz="900" b="1" dirty="0">
                 <a:solidFill>
                   <a:srgbClr val="1F2937"/>
                 </a:solidFill>
@@ -5668,13 +5590,13 @@
                 <a:ea typeface="Calibri" pitchFamily="34" charset="-122"/>
                 <a:cs typeface="Calibri" pitchFamily="34" charset="-120"/>
               </a:rPr>
-              <a:t>Lung laceration (right-lung perimeter)  </a:t>
+              <a:t>Lung laceration (right-lung perimeter)</a:t>
             </a:r>
             <a:pPr indent="0" marL="0">
               <a:buNone/>
             </a:pPr>
             <a:r>
-              <a:rPr lang="en-US" sz="860" dirty="0">
+              <a:rPr lang="en-US" sz="900" dirty="0">
                 <a:solidFill>
                   <a:srgbClr val="6B7280"/>
                 </a:solidFill>
@@ -5682,9 +5604,110 @@
                 <a:ea typeface="Calibri" pitchFamily="34" charset="-122"/>
                 <a:cs typeface="Calibri" pitchFamily="34" charset="-120"/>
               </a:rPr>
-              <a:t>· 42 QC-tagged + 8 at harvest (9/9)</a:t>
+              <a:t>  —  </a:t>
             </a:r>
-            <a:endParaRPr lang="en-US" sz="860" dirty="0"/>
+            <a:pPr indent="0" marL="0">
+              <a:buNone/>
+            </a:pPr>
+            <a:r>
+              <a:rPr lang="en-US" sz="900" b="1" dirty="0">
+                <a:solidFill>
+                  <a:srgbClr val="1F2937"/>
+                </a:solidFill>
+                <a:latin typeface="Calibri" pitchFamily="34" charset="0"/>
+                <a:ea typeface="Calibri" pitchFamily="34" charset="-122"/>
+                <a:cs typeface="Calibri" pitchFamily="34" charset="-120"/>
+              </a:rPr>
+              <a:t>50</a:t>
+            </a:r>
+            <a:endParaRPr lang="en-US" sz="900" dirty="0"/>
+          </a:p>
+        </p:txBody>
+      </p:sp>
+      <p:sp>
+        <p:nvSpPr>
+          <p:cNvPr id="11" name="Shape 7"/>
+          <p:cNvSpPr/>
+          <p:nvPr/>
+        </p:nvSpPr>
+        <p:spPr>
+          <a:xfrm>
+            <a:off x="411480" y="4114800"/>
+            <a:ext cx="1152144" cy="146304"/>
+          </a:xfrm>
+          <a:prstGeom prst="rect">
+            <a:avLst/>
+          </a:prstGeom>
+          <a:solidFill>
+            <a:srgbClr val="0E7490"/>
+          </a:solidFill>
+          <a:ln/>
+        </p:spPr>
+      </p:sp>
+      <p:sp>
+        <p:nvSpPr>
+          <p:cNvPr id="12" name="Text 8"/>
+          <p:cNvSpPr/>
+          <p:nvPr/>
+        </p:nvSpPr>
+        <p:spPr>
+          <a:xfrm>
+            <a:off x="3246120" y="4050792"/>
+            <a:ext cx="8412480" cy="274320"/>
+          </a:xfrm>
+          <a:prstGeom prst="rect">
+            <a:avLst/>
+          </a:prstGeom>
+          <a:noFill/>
+          <a:ln/>
+        </p:spPr>
+        <p:txBody>
+          <a:bodyPr wrap="square" lIns="0" tIns="0" rIns="0" bIns="0" rtlCol="0" anchor="ctr"/>
+          <a:lstStyle/>
+          <a:p>
+            <a:pPr indent="0" marL="0">
+              <a:buNone/>
+            </a:pPr>
+            <a:r>
+              <a:rPr lang="en-US" sz="900" dirty="0">
+                <a:solidFill>
+                  <a:srgbClr val="1F2937"/>
+                </a:solidFill>
+                <a:latin typeface="Calibri" pitchFamily="34" charset="0"/>
+                <a:ea typeface="Calibri" pitchFamily="34" charset="-122"/>
+                <a:cs typeface="Calibri" pitchFamily="34" charset="-120"/>
+              </a:rPr>
+              <a:t>Heart damage / laceration</a:t>
+            </a:r>
+            <a:pPr indent="0" marL="0">
+              <a:buNone/>
+            </a:pPr>
+            <a:r>
+              <a:rPr lang="en-US" sz="900" dirty="0">
+                <a:solidFill>
+                  <a:srgbClr val="6B7280"/>
+                </a:solidFill>
+                <a:latin typeface="Calibri" pitchFamily="34" charset="0"/>
+                <a:ea typeface="Calibri" pitchFamily="34" charset="-122"/>
+                <a:cs typeface="Calibri" pitchFamily="34" charset="-120"/>
+              </a:rPr>
+              <a:t>  —  </a:t>
+            </a:r>
+            <a:pPr indent="0" marL="0">
+              <a:buNone/>
+            </a:pPr>
+            <a:r>
+              <a:rPr lang="en-US" sz="900" b="1" dirty="0">
+                <a:solidFill>
+                  <a:srgbClr val="1F2937"/>
+                </a:solidFill>
+                <a:latin typeface="Calibri" pitchFamily="34" charset="0"/>
+                <a:ea typeface="Calibri" pitchFamily="34" charset="-122"/>
+                <a:cs typeface="Calibri" pitchFamily="34" charset="-120"/>
+              </a:rPr>
+              <a:t>21</a:t>
+            </a:r>
+            <a:endParaRPr lang="en-US" sz="900" dirty="0"/>
           </a:p>
         </p:txBody>
       </p:sp>
@@ -5696,8 +5719,8 @@
         </p:nvSpPr>
         <p:spPr>
           <a:xfrm>
-            <a:off x="411480" y="4032504"/>
-            <a:ext cx="1190549" cy="146304"/>
+            <a:off x="411480" y="4434840"/>
+            <a:ext cx="493776" cy="146304"/>
           </a:xfrm>
           <a:prstGeom prst="rect">
             <a:avLst/>
@@ -5716,8 +5739,8 @@
         </p:nvSpPr>
         <p:spPr>
           <a:xfrm>
-            <a:off x="3337560" y="3968496"/>
-            <a:ext cx="8321040" cy="274320"/>
+            <a:off x="3246120" y="4370832"/>
+            <a:ext cx="8412480" cy="274320"/>
           </a:xfrm>
           <a:prstGeom prst="rect">
             <a:avLst/>
@@ -5733,7 +5756,7 @@
               <a:buNone/>
             </a:pPr>
             <a:r>
-              <a:rPr lang="en-US" sz="860" dirty="0">
+              <a:rPr lang="en-US" sz="900" dirty="0">
                 <a:solidFill>
                   <a:srgbClr val="1F2937"/>
                 </a:solidFill>
@@ -5741,13 +5764,13 @@
                 <a:ea typeface="Calibri" pitchFamily="34" charset="-122"/>
                 <a:cs typeface="Calibri" pitchFamily="34" charset="-120"/>
               </a:rPr>
-              <a:t>Heart damage / laceration  </a:t>
+              <a:t>Missing trachea — harvested for another buyer</a:t>
             </a:r>
             <a:pPr indent="0" marL="0">
               <a:buNone/>
             </a:pPr>
             <a:r>
-              <a:rPr lang="en-US" sz="860" dirty="0">
+              <a:rPr lang="en-US" sz="900" dirty="0">
                 <a:solidFill>
                   <a:srgbClr val="6B7280"/>
                 </a:solidFill>
@@ -5755,9 +5778,23 @@
                 <a:ea typeface="Calibri" pitchFamily="34" charset="-122"/>
                 <a:cs typeface="Calibri" pitchFamily="34" charset="-120"/>
               </a:rPr>
-              <a:t>· 21 QC-tagged</a:t>
+              <a:t>  —  </a:t>
             </a:r>
-            <a:endParaRPr lang="en-US" sz="860" dirty="0"/>
+            <a:pPr indent="0" marL="0">
+              <a:buNone/>
+            </a:pPr>
+            <a:r>
+              <a:rPr lang="en-US" sz="900" b="1" dirty="0">
+                <a:solidFill>
+                  <a:srgbClr val="1F2937"/>
+                </a:solidFill>
+                <a:latin typeface="Calibri" pitchFamily="34" charset="0"/>
+                <a:ea typeface="Calibri" pitchFamily="34" charset="-122"/>
+                <a:cs typeface="Calibri" pitchFamily="34" charset="-120"/>
+              </a:rPr>
+              <a:t>9</a:t>
+            </a:r>
+            <a:endParaRPr lang="en-US" sz="900" dirty="0"/>
           </a:p>
         </p:txBody>
       </p:sp>
@@ -5769,8 +5806,8 @@
         </p:nvSpPr>
         <p:spPr>
           <a:xfrm>
-            <a:off x="411480" y="4343400"/>
-            <a:ext cx="510235" cy="146304"/>
+            <a:off x="411480" y="4754880"/>
+            <a:ext cx="109728" cy="146304"/>
           </a:xfrm>
           <a:prstGeom prst="rect">
             <a:avLst/>
@@ -5789,8 +5826,8 @@
         </p:nvSpPr>
         <p:spPr>
           <a:xfrm>
-            <a:off x="3337560" y="4279392"/>
-            <a:ext cx="8321040" cy="274320"/>
+            <a:off x="3246120" y="4690872"/>
+            <a:ext cx="8412480" cy="274320"/>
           </a:xfrm>
           <a:prstGeom prst="rect">
             <a:avLst/>
@@ -5806,7 +5843,7 @@
               <a:buNone/>
             </a:pPr>
             <a:r>
-              <a:rPr lang="en-US" sz="860" dirty="0">
+              <a:rPr lang="en-US" sz="900" dirty="0">
                 <a:solidFill>
                   <a:srgbClr val="1F2937"/>
                 </a:solidFill>
@@ -5814,13 +5851,13 @@
                 <a:ea typeface="Calibri" pitchFamily="34" charset="-122"/>
                 <a:cs typeface="Calibri" pitchFamily="34" charset="-120"/>
               </a:rPr>
-              <a:t>Missing trachea — harvested for another buyer  </a:t>
+              <a:t>Undocumented</a:t>
             </a:r>
             <a:pPr indent="0" marL="0">
               <a:buNone/>
             </a:pPr>
             <a:r>
-              <a:rPr lang="en-US" sz="860" dirty="0">
+              <a:rPr lang="en-US" sz="900" dirty="0">
                 <a:solidFill>
                   <a:srgbClr val="6B7280"/>
                 </a:solidFill>
@@ -5828,58 +5865,13 @@
                 <a:ea typeface="Calibri" pitchFamily="34" charset="-122"/>
                 <a:cs typeface="Calibri" pitchFamily="34" charset="-120"/>
               </a:rPr>
-              <a:t>· 9 at harvest (9/9)</a:t>
+              <a:t>  —  </a:t>
             </a:r>
-            <a:endParaRPr lang="en-US" sz="860" dirty="0"/>
-          </a:p>
-        </p:txBody>
-      </p:sp>
-      <p:sp>
-        <p:nvSpPr>
-          <p:cNvPr id="17" name="Shape 13"/>
-          <p:cNvSpPr/>
-          <p:nvPr/>
-        </p:nvSpPr>
-        <p:spPr>
-          <a:xfrm>
-            <a:off x="411480" y="4654296"/>
-            <a:ext cx="109728" cy="146304"/>
-          </a:xfrm>
-          <a:prstGeom prst="rect">
-            <a:avLst/>
-          </a:prstGeom>
-          <a:solidFill>
-            <a:srgbClr val="0E7490"/>
-          </a:solidFill>
-          <a:ln/>
-        </p:spPr>
-      </p:sp>
-      <p:sp>
-        <p:nvSpPr>
-          <p:cNvPr id="18" name="Text 14"/>
-          <p:cNvSpPr/>
-          <p:nvPr/>
-        </p:nvSpPr>
-        <p:spPr>
-          <a:xfrm>
-            <a:off x="3337560" y="4590288"/>
-            <a:ext cx="8321040" cy="274320"/>
-          </a:xfrm>
-          <a:prstGeom prst="rect">
-            <a:avLst/>
-          </a:prstGeom>
-          <a:noFill/>
-          <a:ln/>
-        </p:spPr>
-        <p:txBody>
-          <a:bodyPr wrap="square" lIns="0" tIns="0" rIns="0" bIns="0" rtlCol="0" anchor="ctr"/>
-          <a:lstStyle/>
-          <a:p>
             <a:pPr indent="0" marL="0">
               <a:buNone/>
             </a:pPr>
             <a:r>
-              <a:rPr lang="en-US" sz="860" dirty="0">
+              <a:rPr lang="en-US" sz="900" b="1" dirty="0">
                 <a:solidFill>
                   <a:srgbClr val="1F2937"/>
                 </a:solidFill>
@@ -5887,74 +5879,21 @@
                 <a:ea typeface="Calibri" pitchFamily="34" charset="-122"/>
                 <a:cs typeface="Calibri" pitchFamily="34" charset="-120"/>
               </a:rPr>
-              <a:t>Undocumented (8/26 QC fail — stage split pending)  </a:t>
+              <a:t>1</a:t>
             </a:r>
-            <a:pPr indent="0" marL="0">
-              <a:buNone/>
-            </a:pPr>
-            <a:r>
-              <a:rPr lang="en-US" sz="860" dirty="0">
-                <a:solidFill>
-                  <a:srgbClr val="6B7280"/>
-                </a:solidFill>
-                <a:latin typeface="Calibri" pitchFamily="34" charset="0"/>
-                <a:ea typeface="Calibri" pitchFamily="34" charset="-122"/>
-                <a:cs typeface="Calibri" pitchFamily="34" charset="-120"/>
-              </a:rPr>
-              <a:t>· 1</a:t>
-            </a:r>
-            <a:endParaRPr lang="en-US" sz="860" dirty="0"/>
+            <a:endParaRPr lang="en-US" sz="900" dirty="0"/>
           </a:p>
         </p:txBody>
       </p:sp>
       <p:sp>
         <p:nvSpPr>
-          <p:cNvPr id="19" name="Text 15"/>
+          <p:cNvPr id="17" name="Text 13"/>
           <p:cNvSpPr/>
           <p:nvPr/>
         </p:nvSpPr>
         <p:spPr>
           <a:xfrm>
-            <a:off x="411480" y="4937760"/>
-            <a:ext cx="5669280" cy="219456"/>
-          </a:xfrm>
-          <a:prstGeom prst="rect">
-            <a:avLst/>
-          </a:prstGeom>
-          <a:noFill/>
-          <a:ln/>
-        </p:spPr>
-        <p:txBody>
-          <a:bodyPr wrap="square" lIns="0" tIns="0" rIns="0" bIns="0" rtlCol="0" anchor="ctr"/>
-          <a:lstStyle/>
-          <a:p>
-            <a:pPr indent="0" marL="0">
-              <a:buNone/>
-            </a:pPr>
-            <a:r>
-              <a:rPr lang="en-US" sz="760" i="1" dirty="0">
-                <a:solidFill>
-                  <a:srgbClr val="6B7280"/>
-                </a:solidFill>
-                <a:latin typeface="Calibri" pitchFamily="34" charset="0"/>
-                <a:ea typeface="Calibri" pitchFamily="34" charset="-122"/>
-                <a:cs typeface="Calibri" pitchFamily="34" charset="-120"/>
-              </a:rPr>
-              <a:t>Harvest-stage reject reasons for 8/26 (Jordan's 9) not itemized — requested from Kris/Jordan.</a:t>
-            </a:r>
-            <a:endParaRPr lang="en-US" sz="760" dirty="0"/>
-          </a:p>
-        </p:txBody>
-      </p:sp>
-      <p:sp>
-        <p:nvSpPr>
-          <p:cNvPr id="20" name="Text 16"/>
-          <p:cNvSpPr/>
-          <p:nvPr/>
-        </p:nvSpPr>
-        <p:spPr>
-          <a:xfrm>
-            <a:off x="6172200" y="3401568"/>
+            <a:off x="6172200" y="3456432"/>
             <a:ext cx="5577840" cy="219456"/>
           </a:xfrm>
           <a:prstGeom prst="rect">
@@ -5979,7 +5918,7 @@
                 <a:ea typeface="Calibri" pitchFamily="34" charset="-122"/>
                 <a:cs typeface="Calibri" pitchFamily="34" charset="-120"/>
               </a:rPr>
-              <a:t>ATM receipt confirms it — every scrap unit on these batches is 9972 Laceration/Cut</a:t>
+              <a:t>ATM receipt — every scrap unit on these batches: 9972 Laceration/Cut</a:t>
             </a:r>
             <a:endParaRPr lang="en-US" sz="1000" dirty="0"/>
           </a:p>
@@ -6000,7 +5939,7 @@
           </p:nvPr>
         </p:nvGraphicFramePr>
         <p:xfrm>
-          <a:off x="6172200" y="3657600"/>
+          <a:off x="6172200" y="3749040"/>
           <a:ext cx="5577840" cy="914400"/>
         </p:xfrm>
         <a:graphic>
@@ -6013,7 +5952,7 @@
                 <a:gridCol w="1417320"/>
                 <a:gridCol w="1417320"/>
               </a:tblGrid>
-              <a:tr h="219456">
+              <a:tr h="237744">
                 <a:tc>
                   <a:txBody>
                     <a:bodyPr/>
@@ -6287,7 +6226,7 @@
                   </a:tcPr>
                 </a:tc>
               </a:tr>
-              <a:tr h="219456">
+              <a:tr h="237744">
                 <a:tc>
                   <a:txBody>
                     <a:bodyPr/>
@@ -6549,7 +6488,7 @@
                   </a:tcPr>
                 </a:tc>
               </a:tr>
-              <a:tr h="219456">
+              <a:tr h="237744">
                 <a:tc>
                   <a:txBody>
                     <a:bodyPr/>
@@ -6811,7 +6750,7 @@
                   </a:tcPr>
                 </a:tc>
               </a:tr>
-              <a:tr h="219456">
+              <a:tr h="237744">
                 <a:tc>
                   <a:txBody>
                     <a:bodyPr/>
@@ -7073,7 +7012,7 @@
                   </a:tcPr>
                 </a:tc>
               </a:tr>
-              <a:tr h="219456">
+              <a:tr h="237744">
                 <a:tc>
                   <a:txBody>
                     <a:bodyPr/>
@@ -7341,57 +7280,18 @@
       </p:graphicFrame>
       <p:sp>
         <p:nvSpPr>
-          <p:cNvPr id="22" name="Text 17"/>
+          <p:cNvPr id="19" name="Shape 14"/>
           <p:cNvSpPr/>
           <p:nvPr/>
         </p:nvSpPr>
         <p:spPr>
           <a:xfrm>
-            <a:off x="6172200" y="4828032"/>
-            <a:ext cx="5577840" cy="329184"/>
-          </a:xfrm>
-          <a:prstGeom prst="rect">
-            <a:avLst/>
-          </a:prstGeom>
-          <a:noFill/>
-          <a:ln/>
-        </p:spPr>
-        <p:txBody>
-          <a:bodyPr wrap="square" lIns="0" tIns="0" rIns="0" bIns="0" rtlCol="0" anchor="ctr"/>
-          <a:lstStyle/>
-          <a:p>
-            <a:pPr indent="0" marL="0">
-              <a:buNone/>
-            </a:pPr>
-            <a:r>
-              <a:rPr lang="en-US" sz="800" i="1" dirty="0">
-                <a:solidFill>
-                  <a:srgbClr val="6B7280"/>
-                </a:solidFill>
-                <a:latin typeface="Calibri" pitchFamily="34" charset="0"/>
-                <a:ea typeface="Calibri" pitchFamily="34" charset="-122"/>
-                <a:cs typeface="Calibri" pitchFamily="34" charset="-120"/>
-              </a:rPr>
-              <a:t>SH-passed survivors keep failing on the same lacerations after freeze/thaw — harvesting-side damage confirmed at both stages, ~2–4 weeks apart.</a:t>
-            </a:r>
-            <a:endParaRPr lang="en-US" sz="800" dirty="0"/>
-          </a:p>
-        </p:txBody>
-      </p:sp>
-      <p:sp>
-        <p:nvSpPr>
-          <p:cNvPr id="23" name="Shape 18"/>
-          <p:cNvSpPr/>
-          <p:nvPr/>
-        </p:nvSpPr>
-        <p:spPr>
-          <a:xfrm>
-            <a:off x="411480" y="5230368"/>
-            <a:ext cx="5806440" cy="1371600"/>
+            <a:off x="411480" y="5166360"/>
+            <a:ext cx="5806440" cy="1463040"/>
           </a:xfrm>
           <a:prstGeom prst="roundRect">
             <a:avLst>
-              <a:gd name="adj" fmla="val 3333"/>
+              <a:gd name="adj" fmla="val 3125"/>
             </a:avLst>
           </a:prstGeom>
           <a:solidFill>
@@ -7402,13 +7302,13 @@
       </p:sp>
       <p:sp>
         <p:nvSpPr>
-          <p:cNvPr id="24" name="Text 19"/>
+          <p:cNvPr id="20" name="Text 15"/>
           <p:cNvSpPr/>
           <p:nvPr/>
         </p:nvSpPr>
         <p:spPr>
           <a:xfrm>
-            <a:off x="576072" y="5303520"/>
+            <a:off x="576072" y="5248656"/>
             <a:ext cx="2743200" cy="201168"/>
           </a:xfrm>
           <a:prstGeom prst="rect">
@@ -7441,14 +7341,14 @@
       </p:sp>
       <p:sp>
         <p:nvSpPr>
-          <p:cNvPr id="25" name="Text 20"/>
+          <p:cNvPr id="21" name="Text 16"/>
           <p:cNvSpPr/>
           <p:nvPr/>
         </p:nvSpPr>
         <p:spPr>
           <a:xfrm>
-            <a:off x="603504" y="5522976"/>
-            <a:ext cx="5486400" cy="1005840"/>
+            <a:off x="603504" y="5468112"/>
+            <a:ext cx="5486400" cy="1097280"/>
           </a:xfrm>
           <a:prstGeom prst="rect">
             <a:avLst/>
@@ -7468,7 +7368,7 @@
               <a:buChar char="➢"/>
             </a:pPr>
             <a:r>
-              <a:rPr lang="en-US" sz="820" dirty="0">
+              <a:rPr lang="en-US" sz="840" dirty="0">
                 <a:solidFill>
                   <a:srgbClr val="1F2937"/>
                 </a:solidFill>
@@ -7476,9 +7376,9 @@
                 <a:ea typeface="Calibri" pitchFamily="34" charset="-122"/>
                 <a:cs typeface="Calibri" pitchFamily="34" charset="-120"/>
               </a:rPr>
-              <a:t>Net: 24 usable thoracics from 113 at harvest (21.2%) over six visits — a harvesting problem, not a screening one: our QC accepted 88.9–100% of what Jordan passed.</a:t>
+              <a:t>24 usable thoracics from 113 at harvest (21.2%) over six visits — a harvesting problem, not a screening one: our QC accepted 88.9–100% of what Jordan passed.</a:t>
             </a:r>
-            <a:endParaRPr lang="en-US" sz="820" dirty="0"/>
+            <a:endParaRPr lang="en-US" sz="840" dirty="0"/>
           </a:p>
           <a:p>
             <a:pPr marL="342900" indent="-342900">
@@ -7489,7 +7389,7 @@
               <a:buChar char="➢"/>
             </a:pPr>
             <a:r>
-              <a:rPr lang="en-US" sz="820" dirty="0">
+              <a:rPr lang="en-US" sz="840" dirty="0">
                 <a:solidFill>
                   <a:srgbClr val="1F2937"/>
                 </a:solidFill>
@@ -7499,7 +7399,7 @@
               </a:rPr>
               <a:t>Two levers proved real: Francisco's team engagement preceded the 8/26 rebound to 44.4%, and Jordan's harvest screen aligns with our spec.</a:t>
             </a:r>
-            <a:endParaRPr lang="en-US" sz="820" dirty="0"/>
+            <a:endParaRPr lang="en-US" sz="840" dirty="0"/>
           </a:p>
           <a:p>
             <a:pPr marL="342900" indent="-342900">
@@ -7510,7 +7410,7 @@
               <a:buChar char="➢"/>
             </a:pPr>
             <a:r>
-              <a:rPr lang="en-US" sz="820" dirty="0">
+              <a:rPr lang="en-US" sz="840" dirty="0">
                 <a:solidFill>
                   <a:srgbClr val="1F2937"/>
                 </a:solidFill>
@@ -7520,24 +7420,24 @@
               </a:rPr>
               <a:t>9/9 collapse (10.5%) is mostly commercial, not technique: 9 of 17 rejects were missing trachea — tracheas go to another buyer.</a:t>
             </a:r>
-            <a:endParaRPr lang="en-US" sz="820" dirty="0"/>
+            <a:endParaRPr lang="en-US" sz="840" dirty="0"/>
           </a:p>
         </p:txBody>
       </p:sp>
       <p:sp>
         <p:nvSpPr>
-          <p:cNvPr id="26" name="Shape 21"/>
+          <p:cNvPr id="22" name="Shape 17"/>
           <p:cNvSpPr/>
           <p:nvPr/>
         </p:nvSpPr>
         <p:spPr>
           <a:xfrm>
-            <a:off x="6382512" y="5230368"/>
-            <a:ext cx="5394960" cy="1371600"/>
+            <a:off x="6382512" y="5166360"/>
+            <a:ext cx="5394960" cy="1463040"/>
           </a:xfrm>
           <a:prstGeom prst="roundRect">
             <a:avLst>
-              <a:gd name="adj" fmla="val 3333"/>
+              <a:gd name="adj" fmla="val 3125"/>
             </a:avLst>
           </a:prstGeom>
           <a:solidFill>
@@ -7553,13 +7453,13 @@
       </p:sp>
       <p:sp>
         <p:nvSpPr>
-          <p:cNvPr id="27" name="Text 22"/>
+          <p:cNvPr id="23" name="Text 18"/>
           <p:cNvSpPr/>
           <p:nvPr/>
         </p:nvSpPr>
         <p:spPr>
           <a:xfrm>
-            <a:off x="6547104" y="5303520"/>
+            <a:off x="6547104" y="5248656"/>
             <a:ext cx="2743200" cy="201168"/>
           </a:xfrm>
           <a:prstGeom prst="rect">
@@ -7592,14 +7492,14 @@
       </p:sp>
       <p:sp>
         <p:nvSpPr>
-          <p:cNvPr id="28" name="Text 23"/>
+          <p:cNvPr id="24" name="Text 19"/>
           <p:cNvSpPr/>
           <p:nvPr/>
         </p:nvSpPr>
         <p:spPr>
           <a:xfrm>
-            <a:off x="6574536" y="5522976"/>
-            <a:ext cx="5074920" cy="1005840"/>
+            <a:off x="6574536" y="5468112"/>
+            <a:ext cx="5074920" cy="1097280"/>
           </a:xfrm>
           <a:prstGeom prst="rect">
             <a:avLst/>
@@ -7619,7 +7519,7 @@
               <a:buChar char="➢"/>
             </a:pPr>
             <a:r>
-              <a:rPr lang="en-US" sz="820" dirty="0">
+              <a:rPr lang="en-US" sz="840" dirty="0">
                 <a:solidFill>
                   <a:srgbClr val="1F2937"/>
                 </a:solidFill>
@@ -7629,7 +7529,7 @@
               </a:rPr>
               <a:t>Settle the trachea arrangement — it decides thoracic viability at Nahunta.</a:t>
             </a:r>
-            <a:endParaRPr lang="en-US" sz="820" dirty="0"/>
+            <a:endParaRPr lang="en-US" sz="840" dirty="0"/>
           </a:p>
           <a:p>
             <a:pPr marL="342900" indent="-342900">
@@ -7640,7 +7540,7 @@
               <a:buChar char="➢"/>
             </a:pPr>
             <a:r>
-              <a:rPr lang="en-US" sz="820" dirty="0">
+              <a:rPr lang="en-US" sz="840" dirty="0">
                 <a:solidFill>
                   <a:srgbClr val="1F2937"/>
                 </a:solidFill>
@@ -7650,7 +7550,7 @@
               </a:rPr>
               <a:t>Harvest-technique corrective with Francisco's team on lung-perimeter cuts; track Jordan's reject rate as the leading indicator.</a:t>
             </a:r>
-            <a:endParaRPr lang="en-US" sz="820" dirty="0"/>
+            <a:endParaRPr lang="en-US" sz="840" dirty="0"/>
           </a:p>
           <a:p>
             <a:pPr marL="342900" indent="-342900">
@@ -7661,7 +7561,7 @@
               <a:buChar char="➢"/>
             </a:pPr>
             <a:r>
-              <a:rPr lang="en-US" sz="820" dirty="0">
+              <a:rPr lang="en-US" sz="840" dirty="0">
                 <a:solidFill>
                   <a:srgbClr val="1F2937"/>
                 </a:solidFill>
@@ -7669,48 +7569,9 @@
                 <a:ea typeface="Calibri" pitchFamily="34" charset="-122"/>
                 <a:cs typeface="Calibri" pitchFamily="34" charset="-120"/>
               </a:rPr>
-              <a:t>Standard five-number tally every visit; pending data: 8/26 stage split of reasons, ATM review of 5502550281 (50 recv).</a:t>
+              <a:t>Standard five-number tally every visit; ATM review of 5502550281 pending (50 received).</a:t>
             </a:r>
-            <a:endParaRPr lang="en-US" sz="820" dirty="0"/>
-          </a:p>
-        </p:txBody>
-      </p:sp>
-      <p:sp>
-        <p:nvSpPr>
-          <p:cNvPr id="29" name="Text 24"/>
-          <p:cNvSpPr/>
-          <p:nvPr/>
-        </p:nvSpPr>
-        <p:spPr>
-          <a:xfrm>
-            <a:off x="411480" y="6620256"/>
-            <a:ext cx="9144000" cy="201168"/>
-          </a:xfrm>
-          <a:prstGeom prst="rect">
-            <a:avLst/>
-          </a:prstGeom>
-          <a:noFill/>
-          <a:ln/>
-        </p:spPr>
-        <p:txBody>
-          <a:bodyPr wrap="square" lIns="0" tIns="0" rIns="0" bIns="0" rtlCol="0" anchor="ctr"/>
-          <a:lstStyle/>
-          <a:p>
-            <a:pPr indent="0" marL="0">
-              <a:buNone/>
-            </a:pPr>
-            <a:r>
-              <a:rPr lang="en-US" sz="800" i="1" dirty="0">
-                <a:solidFill>
-                  <a:srgbClr val="6B7280"/>
-                </a:solidFill>
-                <a:latin typeface="Calibri" pitchFamily="34" charset="0"/>
-                <a:ea typeface="Calibri" pitchFamily="34" charset="-122"/>
-                <a:cs typeface="Calibri" pitchFamily="34" charset="-120"/>
-              </a:rPr>
-              <a:t>Source: SH_IQC_Inspections.xlsx — 'Nahunta Standard' tab; ATM (SAP) extract 09/16/2026, SH-inspected batches only</a:t>
-            </a:r>
-            <a:endParaRPr lang="en-US" sz="800" dirty="0"/>
+            <a:endParaRPr lang="en-US" sz="840" dirty="0"/>
           </a:p>
         </p:txBody>
       </p:sp>

</xml_diff>

<commit_message>
Thoracic slide: reasons as bar chart with counts on bars (50/21/9/10)
Co-Authored-By: Claude Fable 5 <noreply@anthropic.com>
Claude-Session: https://claude.ai/code/session_014UGcEfvuC9NvQ5rauRTTbR
</commit_message>
<xml_diff>
--- a/QC inspections suppliers/Nahunta_Thoracics_DeepDive.pptx
+++ b/QC inspections suppliers/Nahunta_Thoracics_DeepDive.pptx
@@ -333,6 +333,242 @@
                   <a:srgbClr val="6B7280"/>
                 </a:solidFill>
                 <a:latin typeface="Calibri"/>
+              </a:defRPr>
+            </a:pPr>
+            <a:endParaRPr lang="en-US"/>
+          </a:p>
+        </c:txPr>
+        <c:crossAx val="2094734554"/>
+        <c:crosses val="autoZero"/>
+        <c:crossBetween val="between"/>
+      </c:valAx>
+      <c:spPr>
+        <a:noFill/>
+        <a:ln>
+          <a:noFill/>
+        </a:ln>
+        <a:effectLst/>
+      </c:spPr>
+    </c:plotArea>
+    <c:plotVisOnly val="1"/>
+    <c:dispBlanksAs val="span"/>
+  </c:chart>
+  <c:spPr>
+    <a:noFill/>
+    <a:ln>
+      <a:noFill/>
+    </a:ln>
+    <a:effectLst/>
+  </c:spPr>
+  <c:externalData r:id="rId1">
+    <c:autoUpdate val="0"/>
+  </c:externalData>
+</c:chartSpace>
+</file>
+
+<file path=ppt/charts/chart2.xml><?xml version="1.0" encoding="utf-8"?>
+<c:chartSpace xmlns:c="http://schemas.openxmlformats.org/drawingml/2006/chart" xmlns:a="http://schemas.openxmlformats.org/drawingml/2006/main" xmlns:r="http://schemas.openxmlformats.org/officeDocument/2006/relationships">
+  <c:date1904 val="0"/>
+  <c:roundedCorners val="1"/>
+  <c:chart>
+    <c:autoTitleDeleted val="1"/>
+    <c:plotArea>
+      <c:layout/>
+      <c:barChart>
+        <c:barDir val="bar"/>
+        <c:grouping val="clustered"/>
+        <c:varyColors val="0"/>
+        <c:ser>
+          <c:idx val="0"/>
+          <c:order val="0"/>
+          <c:tx>
+            <c:strRef>
+              <c:f>Sheet1!$B$1</c:f>
+              <c:strCache>
+                <c:ptCount val="1"/>
+                <c:pt idx="0">
+                  <c:v>Rejects</c:v>
+                </c:pt>
+              </c:strCache>
+            </c:strRef>
+          </c:tx>
+          <c:spPr>
+            <a:solidFill>
+              <a:srgbClr val="0E7490"/>
+            </a:solidFill>
+            <a:effectLst/>
+          </c:spPr>
+          <c:invertIfNegative val="0"/>
+          <c:dLbls>
+            <c:numFmt formatCode="0" sourceLinked="0"/>
+            <c:txPr>
+              <a:bodyPr/>
+              <a:lstStyle/>
+              <a:p>
+                <a:pPr>
+                  <a:defRPr b="0" i="0" strike="noStrike" sz="1000" u="none">
+                    <a:solidFill>
+                      <a:srgbClr val="1F2937"/>
+                    </a:solidFill>
+                    <a:latin typeface="Calibri"/>
+                  </a:defRPr>
+                </a:pPr>
+              </a:p>
+            </c:txPr>
+            <c:showLegendKey val="0"/>
+            <c:showVal val="1"/>
+            <c:showCatName val="0"/>
+            <c:showSerName val="0"/>
+            <c:showPercent val="0"/>
+            <c:showBubbleSize val="0"/>
+            <c:showLeaderLines val="0"/>
+          </c:dLbls>
+          <c:cat>
+            <c:multiLvlStrRef>
+              <c:f>Sheet1!$A$2:$A$5</c:f>
+              <c:multiLvlStrCache>
+                <c:ptCount val="4"/>
+                <c:lvl>
+                  <c:pt idx="0">
+                    <c:v>Not itemized (8/26 harvest 9 + QC 1)</c:v>
+                  </c:pt>
+                  <c:pt idx="1">
+                    <c:v>Missing trachea — other buyer</c:v>
+                  </c:pt>
+                  <c:pt idx="2">
+                    <c:v>Heart damage / laceration</c:v>
+                  </c:pt>
+                  <c:pt idx="3">
+                    <c:v>Lung laceration (right-lung perimeter)</c:v>
+                  </c:pt>
+                </c:lvl>
+              </c:multiLvlStrCache>
+            </c:multiLvlStrRef>
+          </c:cat>
+          <c:val>
+            <c:numRef>
+              <c:f>Sheet1!$B$2:$B$5</c:f>
+              <c:numCache>
+                <c:formatCode>General</c:formatCode>
+                <c:ptCount val="4"/>
+                <c:pt idx="0">
+                  <c:v>10</c:v>
+                </c:pt>
+                <c:pt idx="1">
+                  <c:v>9</c:v>
+                </c:pt>
+                <c:pt idx="2">
+                  <c:v>21</c:v>
+                </c:pt>
+                <c:pt idx="3">
+                  <c:v>50</c:v>
+                </c:pt>
+              </c:numCache>
+            </c:numRef>
+          </c:val>
+        </c:ser>
+        <c:dLbls>
+          <c:numFmt formatCode="0" sourceLinked="0"/>
+          <c:txPr>
+            <a:bodyPr/>
+            <a:lstStyle/>
+            <a:p>
+              <a:pPr>
+                <a:defRPr b="0" i="0" strike="noStrike" sz="1000" u="none">
+                  <a:solidFill>
+                    <a:srgbClr val="1F2937"/>
+                  </a:solidFill>
+                  <a:latin typeface="Calibri"/>
+                </a:defRPr>
+              </a:pPr>
+            </a:p>
+          </c:txPr>
+          <c:showLegendKey val="0"/>
+          <c:showVal val="1"/>
+          <c:showCatName val="0"/>
+          <c:showSerName val="0"/>
+          <c:showPercent val="0"/>
+          <c:showBubbleSize val="0"/>
+          <c:showLeaderLines val="0"/>
+        </c:dLbls>
+        <c:gapWidth val="40"/>
+        <c:overlap val="0"/>
+        <c:axId val="2094734554"/>
+        <c:axId val="2094734552"/>
+        <c:axId val="2094734556"/>
+      </c:barChart>
+      <c:catAx>
+        <c:axId val="2094734554"/>
+        <c:scaling>
+          <c:orientation val="minMax"/>
+        </c:scaling>
+        <c:delete val="0"/>
+        <c:axPos val="l"/>
+        <c:numFmt formatCode="General" sourceLinked="1"/>
+        <c:majorTickMark val="out"/>
+        <c:minorTickMark val="none"/>
+        <c:tickLblPos val="nextTo"/>
+        <c:spPr>
+          <a:ln w="12700" cap="flat">
+            <a:solidFill>
+              <a:srgbClr val="888888"/>
+            </a:solidFill>
+            <a:prstDash val="solid"/>
+            <a:round/>
+          </a:ln>
+        </c:spPr>
+        <c:txPr>
+          <a:bodyPr/>
+          <a:lstStyle/>
+          <a:p>
+            <a:pPr>
+              <a:defRPr sz="850" b="0" i="0" u="none" strike="noStrike">
+                <a:solidFill>
+                  <a:srgbClr val="1F2937"/>
+                </a:solidFill>
+                <a:latin typeface="Calibri"/>
+              </a:defRPr>
+            </a:pPr>
+            <a:endParaRPr lang="en-US"/>
+          </a:p>
+        </c:txPr>
+        <c:crossAx val="2094734552"/>
+        <c:crosses val="autoZero"/>
+        <c:auto val="1"/>
+        <c:lblAlgn val="ctr"/>
+        <c:noMultiLvlLbl val="1"/>
+      </c:catAx>
+      <c:valAx>
+        <c:axId val="2094734552"/>
+        <c:scaling>
+          <c:orientation val="minMax"/>
+          <c:max val="55"/>
+        </c:scaling>
+        <c:delete val="1"/>
+        <c:axPos val="b"/>
+        <c:numFmt formatCode="General" sourceLinked="0"/>
+        <c:majorTickMark val="out"/>
+        <c:minorTickMark val="none"/>
+        <c:tickLblPos val="low"/>
+        <c:spPr>
+          <a:ln w="12700" cap="flat">
+            <a:solidFill>
+              <a:srgbClr val="888888"/>
+            </a:solidFill>
+            <a:prstDash val="solid"/>
+            <a:round/>
+          </a:ln>
+        </c:spPr>
+        <c:txPr>
+          <a:bodyPr/>
+          <a:lstStyle/>
+          <a:p>
+            <a:pPr>
+              <a:defRPr sz="1200" b="0" i="0" u="none" strike="noStrike">
+                <a:solidFill>
+                  <a:srgbClr val="000000"/>
+                </a:solidFill>
+                <a:latin typeface="Arial"/>
               </a:defRPr>
             </a:pPr>
             <a:endParaRPr lang="en-US"/>
@@ -5531,363 +5767,31 @@
                 <a:ea typeface="Calibri" pitchFamily="34" charset="-122"/>
                 <a:cs typeface="Calibri" pitchFamily="34" charset="-120"/>
               </a:rPr>
-              <a:t>What's failing — reasons</a:t>
+              <a:t>What's failing — reasons, all stages (tagged rejects)</a:t>
             </a:r>
             <a:endParaRPr lang="en-US" sz="1000" dirty="0"/>
           </a:p>
         </p:txBody>
       </p:sp>
+      <p:graphicFrame>
+        <p:nvGraphicFramePr>
+          <p:cNvPr id="9" name="Chart 1" descr=""/>
+          <p:cNvGraphicFramePr/>
+          <p:nvPr/>
+        </p:nvGraphicFramePr>
+        <p:xfrm>
+          <a:off x="411480" y="3675888"/>
+          <a:ext cx="5577840" cy="1371600"/>
+        </p:xfrm>
+        <a:graphic xmlns:a="http://schemas.openxmlformats.org/drawingml/2006/main">
+          <a:graphicData uri="http://schemas.openxmlformats.org/drawingml/2006/chart">
+            <c:chart xmlns:c="http://schemas.openxmlformats.org/drawingml/2006/chart" r:id="rId2"/>
+          </a:graphicData>
+        </a:graphic>
+      </p:graphicFrame>
       <p:sp>
         <p:nvSpPr>
-          <p:cNvPr id="9" name="Shape 5"/>
-          <p:cNvSpPr/>
-          <p:nvPr/>
-        </p:nvSpPr>
-        <p:spPr>
-          <a:xfrm>
-            <a:off x="411480" y="3794760"/>
-            <a:ext cx="2743200" cy="146304"/>
-          </a:xfrm>
-          <a:prstGeom prst="rect">
-            <a:avLst/>
-          </a:prstGeom>
-          <a:solidFill>
-            <a:srgbClr val="DC2626"/>
-          </a:solidFill>
-          <a:ln/>
-        </p:spPr>
-      </p:sp>
-      <p:sp>
-        <p:nvSpPr>
-          <p:cNvPr id="10" name="Text 6"/>
-          <p:cNvSpPr/>
-          <p:nvPr/>
-        </p:nvSpPr>
-        <p:spPr>
-          <a:xfrm>
-            <a:off x="3246120" y="3730752"/>
-            <a:ext cx="8412480" cy="274320"/>
-          </a:xfrm>
-          <a:prstGeom prst="rect">
-            <a:avLst/>
-          </a:prstGeom>
-          <a:noFill/>
-          <a:ln/>
-        </p:spPr>
-        <p:txBody>
-          <a:bodyPr wrap="square" lIns="0" tIns="0" rIns="0" bIns="0" rtlCol="0" anchor="ctr"/>
-          <a:lstStyle/>
-          <a:p>
-            <a:pPr indent="0" marL="0">
-              <a:buNone/>
-            </a:pPr>
-            <a:r>
-              <a:rPr lang="en-US" sz="900" b="1" dirty="0">
-                <a:solidFill>
-                  <a:srgbClr val="1F2937"/>
-                </a:solidFill>
-                <a:latin typeface="Calibri" pitchFamily="34" charset="0"/>
-                <a:ea typeface="Calibri" pitchFamily="34" charset="-122"/>
-                <a:cs typeface="Calibri" pitchFamily="34" charset="-120"/>
-              </a:rPr>
-              <a:t>Lung laceration (right-lung perimeter)</a:t>
-            </a:r>
-            <a:pPr indent="0" marL="0">
-              <a:buNone/>
-            </a:pPr>
-            <a:r>
-              <a:rPr lang="en-US" sz="900" dirty="0">
-                <a:solidFill>
-                  <a:srgbClr val="6B7280"/>
-                </a:solidFill>
-                <a:latin typeface="Calibri" pitchFamily="34" charset="0"/>
-                <a:ea typeface="Calibri" pitchFamily="34" charset="-122"/>
-                <a:cs typeface="Calibri" pitchFamily="34" charset="-120"/>
-              </a:rPr>
-              <a:t>  —  </a:t>
-            </a:r>
-            <a:pPr indent="0" marL="0">
-              <a:buNone/>
-            </a:pPr>
-            <a:r>
-              <a:rPr lang="en-US" sz="900" b="1" dirty="0">
-                <a:solidFill>
-                  <a:srgbClr val="1F2937"/>
-                </a:solidFill>
-                <a:latin typeface="Calibri" pitchFamily="34" charset="0"/>
-                <a:ea typeface="Calibri" pitchFamily="34" charset="-122"/>
-                <a:cs typeface="Calibri" pitchFamily="34" charset="-120"/>
-              </a:rPr>
-              <a:t>50</a:t>
-            </a:r>
-            <a:endParaRPr lang="en-US" sz="900" dirty="0"/>
-          </a:p>
-        </p:txBody>
-      </p:sp>
-      <p:sp>
-        <p:nvSpPr>
-          <p:cNvPr id="11" name="Shape 7"/>
-          <p:cNvSpPr/>
-          <p:nvPr/>
-        </p:nvSpPr>
-        <p:spPr>
-          <a:xfrm>
-            <a:off x="411480" y="4114800"/>
-            <a:ext cx="1152144" cy="146304"/>
-          </a:xfrm>
-          <a:prstGeom prst="rect">
-            <a:avLst/>
-          </a:prstGeom>
-          <a:solidFill>
-            <a:srgbClr val="0E7490"/>
-          </a:solidFill>
-          <a:ln/>
-        </p:spPr>
-      </p:sp>
-      <p:sp>
-        <p:nvSpPr>
-          <p:cNvPr id="12" name="Text 8"/>
-          <p:cNvSpPr/>
-          <p:nvPr/>
-        </p:nvSpPr>
-        <p:spPr>
-          <a:xfrm>
-            <a:off x="3246120" y="4050792"/>
-            <a:ext cx="8412480" cy="274320"/>
-          </a:xfrm>
-          <a:prstGeom prst="rect">
-            <a:avLst/>
-          </a:prstGeom>
-          <a:noFill/>
-          <a:ln/>
-        </p:spPr>
-        <p:txBody>
-          <a:bodyPr wrap="square" lIns="0" tIns="0" rIns="0" bIns="0" rtlCol="0" anchor="ctr"/>
-          <a:lstStyle/>
-          <a:p>
-            <a:pPr indent="0" marL="0">
-              <a:buNone/>
-            </a:pPr>
-            <a:r>
-              <a:rPr lang="en-US" sz="900" dirty="0">
-                <a:solidFill>
-                  <a:srgbClr val="1F2937"/>
-                </a:solidFill>
-                <a:latin typeface="Calibri" pitchFamily="34" charset="0"/>
-                <a:ea typeface="Calibri" pitchFamily="34" charset="-122"/>
-                <a:cs typeface="Calibri" pitchFamily="34" charset="-120"/>
-              </a:rPr>
-              <a:t>Heart damage / laceration</a:t>
-            </a:r>
-            <a:pPr indent="0" marL="0">
-              <a:buNone/>
-            </a:pPr>
-            <a:r>
-              <a:rPr lang="en-US" sz="900" dirty="0">
-                <a:solidFill>
-                  <a:srgbClr val="6B7280"/>
-                </a:solidFill>
-                <a:latin typeface="Calibri" pitchFamily="34" charset="0"/>
-                <a:ea typeface="Calibri" pitchFamily="34" charset="-122"/>
-                <a:cs typeface="Calibri" pitchFamily="34" charset="-120"/>
-              </a:rPr>
-              <a:t>  —  </a:t>
-            </a:r>
-            <a:pPr indent="0" marL="0">
-              <a:buNone/>
-            </a:pPr>
-            <a:r>
-              <a:rPr lang="en-US" sz="900" b="1" dirty="0">
-                <a:solidFill>
-                  <a:srgbClr val="1F2937"/>
-                </a:solidFill>
-                <a:latin typeface="Calibri" pitchFamily="34" charset="0"/>
-                <a:ea typeface="Calibri" pitchFamily="34" charset="-122"/>
-                <a:cs typeface="Calibri" pitchFamily="34" charset="-120"/>
-              </a:rPr>
-              <a:t>21</a:t>
-            </a:r>
-            <a:endParaRPr lang="en-US" sz="900" dirty="0"/>
-          </a:p>
-        </p:txBody>
-      </p:sp>
-      <p:sp>
-        <p:nvSpPr>
-          <p:cNvPr id="13" name="Shape 9"/>
-          <p:cNvSpPr/>
-          <p:nvPr/>
-        </p:nvSpPr>
-        <p:spPr>
-          <a:xfrm>
-            <a:off x="411480" y="4434840"/>
-            <a:ext cx="493776" cy="146304"/>
-          </a:xfrm>
-          <a:prstGeom prst="rect">
-            <a:avLst/>
-          </a:prstGeom>
-          <a:solidFill>
-            <a:srgbClr val="0E7490"/>
-          </a:solidFill>
-          <a:ln/>
-        </p:spPr>
-      </p:sp>
-      <p:sp>
-        <p:nvSpPr>
-          <p:cNvPr id="14" name="Text 10"/>
-          <p:cNvSpPr/>
-          <p:nvPr/>
-        </p:nvSpPr>
-        <p:spPr>
-          <a:xfrm>
-            <a:off x="3246120" y="4370832"/>
-            <a:ext cx="8412480" cy="274320"/>
-          </a:xfrm>
-          <a:prstGeom prst="rect">
-            <a:avLst/>
-          </a:prstGeom>
-          <a:noFill/>
-          <a:ln/>
-        </p:spPr>
-        <p:txBody>
-          <a:bodyPr wrap="square" lIns="0" tIns="0" rIns="0" bIns="0" rtlCol="0" anchor="ctr"/>
-          <a:lstStyle/>
-          <a:p>
-            <a:pPr indent="0" marL="0">
-              <a:buNone/>
-            </a:pPr>
-            <a:r>
-              <a:rPr lang="en-US" sz="900" dirty="0">
-                <a:solidFill>
-                  <a:srgbClr val="1F2937"/>
-                </a:solidFill>
-                <a:latin typeface="Calibri" pitchFamily="34" charset="0"/>
-                <a:ea typeface="Calibri" pitchFamily="34" charset="-122"/>
-                <a:cs typeface="Calibri" pitchFamily="34" charset="-120"/>
-              </a:rPr>
-              <a:t>Missing trachea — harvested for another buyer</a:t>
-            </a:r>
-            <a:pPr indent="0" marL="0">
-              <a:buNone/>
-            </a:pPr>
-            <a:r>
-              <a:rPr lang="en-US" sz="900" dirty="0">
-                <a:solidFill>
-                  <a:srgbClr val="6B7280"/>
-                </a:solidFill>
-                <a:latin typeface="Calibri" pitchFamily="34" charset="0"/>
-                <a:ea typeface="Calibri" pitchFamily="34" charset="-122"/>
-                <a:cs typeface="Calibri" pitchFamily="34" charset="-120"/>
-              </a:rPr>
-              <a:t>  —  </a:t>
-            </a:r>
-            <a:pPr indent="0" marL="0">
-              <a:buNone/>
-            </a:pPr>
-            <a:r>
-              <a:rPr lang="en-US" sz="900" b="1" dirty="0">
-                <a:solidFill>
-                  <a:srgbClr val="1F2937"/>
-                </a:solidFill>
-                <a:latin typeface="Calibri" pitchFamily="34" charset="0"/>
-                <a:ea typeface="Calibri" pitchFamily="34" charset="-122"/>
-                <a:cs typeface="Calibri" pitchFamily="34" charset="-120"/>
-              </a:rPr>
-              <a:t>9</a:t>
-            </a:r>
-            <a:endParaRPr lang="en-US" sz="900" dirty="0"/>
-          </a:p>
-        </p:txBody>
-      </p:sp>
-      <p:sp>
-        <p:nvSpPr>
-          <p:cNvPr id="15" name="Shape 11"/>
-          <p:cNvSpPr/>
-          <p:nvPr/>
-        </p:nvSpPr>
-        <p:spPr>
-          <a:xfrm>
-            <a:off x="411480" y="4754880"/>
-            <a:ext cx="109728" cy="146304"/>
-          </a:xfrm>
-          <a:prstGeom prst="rect">
-            <a:avLst/>
-          </a:prstGeom>
-          <a:solidFill>
-            <a:srgbClr val="0E7490"/>
-          </a:solidFill>
-          <a:ln/>
-        </p:spPr>
-      </p:sp>
-      <p:sp>
-        <p:nvSpPr>
-          <p:cNvPr id="16" name="Text 12"/>
-          <p:cNvSpPr/>
-          <p:nvPr/>
-        </p:nvSpPr>
-        <p:spPr>
-          <a:xfrm>
-            <a:off x="3246120" y="4690872"/>
-            <a:ext cx="8412480" cy="274320"/>
-          </a:xfrm>
-          <a:prstGeom prst="rect">
-            <a:avLst/>
-          </a:prstGeom>
-          <a:noFill/>
-          <a:ln/>
-        </p:spPr>
-        <p:txBody>
-          <a:bodyPr wrap="square" lIns="0" tIns="0" rIns="0" bIns="0" rtlCol="0" anchor="ctr"/>
-          <a:lstStyle/>
-          <a:p>
-            <a:pPr indent="0" marL="0">
-              <a:buNone/>
-            </a:pPr>
-            <a:r>
-              <a:rPr lang="en-US" sz="900" dirty="0">
-                <a:solidFill>
-                  <a:srgbClr val="1F2937"/>
-                </a:solidFill>
-                <a:latin typeface="Calibri" pitchFamily="34" charset="0"/>
-                <a:ea typeface="Calibri" pitchFamily="34" charset="-122"/>
-                <a:cs typeface="Calibri" pitchFamily="34" charset="-120"/>
-              </a:rPr>
-              <a:t>Undocumented</a:t>
-            </a:r>
-            <a:pPr indent="0" marL="0">
-              <a:buNone/>
-            </a:pPr>
-            <a:r>
-              <a:rPr lang="en-US" sz="900" dirty="0">
-                <a:solidFill>
-                  <a:srgbClr val="6B7280"/>
-                </a:solidFill>
-                <a:latin typeface="Calibri" pitchFamily="34" charset="0"/>
-                <a:ea typeface="Calibri" pitchFamily="34" charset="-122"/>
-                <a:cs typeface="Calibri" pitchFamily="34" charset="-120"/>
-              </a:rPr>
-              <a:t>  —  </a:t>
-            </a:r>
-            <a:pPr indent="0" marL="0">
-              <a:buNone/>
-            </a:pPr>
-            <a:r>
-              <a:rPr lang="en-US" sz="900" b="1" dirty="0">
-                <a:solidFill>
-                  <a:srgbClr val="1F2937"/>
-                </a:solidFill>
-                <a:latin typeface="Calibri" pitchFamily="34" charset="0"/>
-                <a:ea typeface="Calibri" pitchFamily="34" charset="-122"/>
-                <a:cs typeface="Calibri" pitchFamily="34" charset="-120"/>
-              </a:rPr>
-              <a:t>1</a:t>
-            </a:r>
-            <a:endParaRPr lang="en-US" sz="900" dirty="0"/>
-          </a:p>
-        </p:txBody>
-      </p:sp>
-      <p:sp>
-        <p:nvSpPr>
-          <p:cNvPr id="17" name="Text 13"/>
+          <p:cNvPr id="10" name="Text 5"/>
           <p:cNvSpPr/>
           <p:nvPr/>
         </p:nvSpPr>
@@ -7280,7 +7184,7 @@
       </p:graphicFrame>
       <p:sp>
         <p:nvSpPr>
-          <p:cNvPr id="19" name="Shape 14"/>
+          <p:cNvPr id="12" name="Shape 6"/>
           <p:cNvSpPr/>
           <p:nvPr/>
         </p:nvSpPr>
@@ -7302,7 +7206,7 @@
       </p:sp>
       <p:sp>
         <p:nvSpPr>
-          <p:cNvPr id="20" name="Text 15"/>
+          <p:cNvPr id="13" name="Text 7"/>
           <p:cNvSpPr/>
           <p:nvPr/>
         </p:nvSpPr>
@@ -7341,7 +7245,7 @@
       </p:sp>
       <p:sp>
         <p:nvSpPr>
-          <p:cNvPr id="21" name="Text 16"/>
+          <p:cNvPr id="14" name="Text 8"/>
           <p:cNvSpPr/>
           <p:nvPr/>
         </p:nvSpPr>
@@ -7426,7 +7330,7 @@
       </p:sp>
       <p:sp>
         <p:nvSpPr>
-          <p:cNvPr id="22" name="Shape 17"/>
+          <p:cNvPr id="15" name="Shape 9"/>
           <p:cNvSpPr/>
           <p:nvPr/>
         </p:nvSpPr>
@@ -7453,7 +7357,7 @@
       </p:sp>
       <p:sp>
         <p:nvSpPr>
-          <p:cNvPr id="23" name="Text 18"/>
+          <p:cNvPr id="16" name="Text 10"/>
           <p:cNvSpPr/>
           <p:nvPr/>
         </p:nvSpPr>
@@ -7492,7 +7396,7 @@
       </p:sp>
       <p:sp>
         <p:nvSpPr>
-          <p:cNvPr id="24" name="Text 19"/>
+          <p:cNvPr id="17" name="Text 11"/>
           <p:cNvSpPr/>
           <p:nvPr/>
         </p:nvSpPr>

</xml_diff>